<commit_message>
turned efa analysis into pipeline
deleted lots of unneeded files
</commit_message>
<xml_diff>
--- a/information/What's in the Backbone.pptx
+++ b/information/What's in the Backbone.pptx
@@ -263,7 +263,7 @@
           <a:p>
             <a:fld id="{DC3464DE-BB09-4046-9914-AAE77AD20AD3}" type="datetimeFigureOut">
               <a:rPr lang="de-DE" smtClean="0"/>
-              <a:t>29.01.2026</a:t>
+              <a:t>16.06.2026</a:t>
             </a:fld>
             <a:endParaRPr lang="de-DE"/>
           </a:p>
@@ -461,7 +461,7 @@
           <a:p>
             <a:fld id="{DC3464DE-BB09-4046-9914-AAE77AD20AD3}" type="datetimeFigureOut">
               <a:rPr lang="de-DE" smtClean="0"/>
-              <a:t>29.01.2026</a:t>
+              <a:t>16.06.2026</a:t>
             </a:fld>
             <a:endParaRPr lang="de-DE"/>
           </a:p>
@@ -669,7 +669,7 @@
           <a:p>
             <a:fld id="{DC3464DE-BB09-4046-9914-AAE77AD20AD3}" type="datetimeFigureOut">
               <a:rPr lang="de-DE" smtClean="0"/>
-              <a:t>29.01.2026</a:t>
+              <a:t>16.06.2026</a:t>
             </a:fld>
             <a:endParaRPr lang="de-DE"/>
           </a:p>
@@ -867,7 +867,7 @@
           <a:p>
             <a:fld id="{DC3464DE-BB09-4046-9914-AAE77AD20AD3}" type="datetimeFigureOut">
               <a:rPr lang="de-DE" smtClean="0"/>
-              <a:t>29.01.2026</a:t>
+              <a:t>16.06.2026</a:t>
             </a:fld>
             <a:endParaRPr lang="de-DE"/>
           </a:p>
@@ -1142,7 +1142,7 @@
           <a:p>
             <a:fld id="{DC3464DE-BB09-4046-9914-AAE77AD20AD3}" type="datetimeFigureOut">
               <a:rPr lang="de-DE" smtClean="0"/>
-              <a:t>29.01.2026</a:t>
+              <a:t>16.06.2026</a:t>
             </a:fld>
             <a:endParaRPr lang="de-DE"/>
           </a:p>
@@ -1407,7 +1407,7 @@
           <a:p>
             <a:fld id="{DC3464DE-BB09-4046-9914-AAE77AD20AD3}" type="datetimeFigureOut">
               <a:rPr lang="de-DE" smtClean="0"/>
-              <a:t>29.01.2026</a:t>
+              <a:t>16.06.2026</a:t>
             </a:fld>
             <a:endParaRPr lang="de-DE"/>
           </a:p>
@@ -1819,7 +1819,7 @@
           <a:p>
             <a:fld id="{DC3464DE-BB09-4046-9914-AAE77AD20AD3}" type="datetimeFigureOut">
               <a:rPr lang="de-DE" smtClean="0"/>
-              <a:t>29.01.2026</a:t>
+              <a:t>16.06.2026</a:t>
             </a:fld>
             <a:endParaRPr lang="de-DE"/>
           </a:p>
@@ -1960,7 +1960,7 @@
           <a:p>
             <a:fld id="{DC3464DE-BB09-4046-9914-AAE77AD20AD3}" type="datetimeFigureOut">
               <a:rPr lang="de-DE" smtClean="0"/>
-              <a:t>29.01.2026</a:t>
+              <a:t>16.06.2026</a:t>
             </a:fld>
             <a:endParaRPr lang="de-DE"/>
           </a:p>
@@ -2073,7 +2073,7 @@
           <a:p>
             <a:fld id="{DC3464DE-BB09-4046-9914-AAE77AD20AD3}" type="datetimeFigureOut">
               <a:rPr lang="de-DE" smtClean="0"/>
-              <a:t>29.01.2026</a:t>
+              <a:t>16.06.2026</a:t>
             </a:fld>
             <a:endParaRPr lang="de-DE"/>
           </a:p>
@@ -2384,7 +2384,7 @@
           <a:p>
             <a:fld id="{DC3464DE-BB09-4046-9914-AAE77AD20AD3}" type="datetimeFigureOut">
               <a:rPr lang="de-DE" smtClean="0"/>
-              <a:t>29.01.2026</a:t>
+              <a:t>16.06.2026</a:t>
             </a:fld>
             <a:endParaRPr lang="de-DE"/>
           </a:p>
@@ -2672,7 +2672,7 @@
           <a:p>
             <a:fld id="{DC3464DE-BB09-4046-9914-AAE77AD20AD3}" type="datetimeFigureOut">
               <a:rPr lang="de-DE" smtClean="0"/>
-              <a:t>29.01.2026</a:t>
+              <a:t>16.06.2026</a:t>
             </a:fld>
             <a:endParaRPr lang="de-DE"/>
           </a:p>
@@ -2913,7 +2913,7 @@
           <a:p>
             <a:fld id="{DC3464DE-BB09-4046-9914-AAE77AD20AD3}" type="datetimeFigureOut">
               <a:rPr lang="de-DE" smtClean="0"/>
-              <a:t>29.01.2026</a:t>
+              <a:t>16.06.2026</a:t>
             </a:fld>
             <a:endParaRPr lang="de-DE"/>
           </a:p>
@@ -4493,15 +4493,7 @@
           <a:p>
             <a:r>
               <a:rPr lang="de-DE" dirty="0"/>
-              <a:t>Custom „Backbone“ – </a:t>
-            </a:r>
-            <a:r>
-              <a:rPr lang="de-DE" dirty="0" err="1"/>
-              <a:t>eigentklich</a:t>
-            </a:r>
-            <a:r>
-              <a:rPr lang="de-DE" dirty="0"/>
-              <a:t> nur </a:t>
+              <a:t>Custom „Backbone“ – eigentlich nur </a:t>
             </a:r>
             <a:r>
               <a:rPr lang="de-DE" dirty="0" err="1"/>

</xml_diff>